<commit_message>
presentacion8: pptx reexportado con la filmina del tiempo nominal
</commit_message>
<xml_diff>
--- a/presentaciones/presentacion8_19_10/presentacion8_19_10.pptx
+++ b/presentaciones/presentacion8_19_10/presentacion8_19_10.pptx
@@ -21,9 +21,10 @@
     <p:sldId id="269" r:id="rId15"/>
     <p:sldId id="270" r:id="rId16"/>
     <p:sldId id="271" r:id="rId17"/>
+    <p:sldId id="272" r:id="rId18"/>
   </p:sldIdLst>
   <p:notesMasterIdLst>
-    <p:notesMasterId r:id="rId18"/>
+    <p:notesMasterId r:id="rId19"/>
   </p:notesMasterIdLst>
   <p:sldSz cx="12192000" cy="6858000"/>
   <p:notesSz cx="6858000" cy="12192000"/>
@@ -1045,7 +1046,7 @@
           <a:p>
             <a:r>
               <a:rPr lang="en-US" dirty="0"/>
-              <a:t>En el código, líneas 337–348: MUs[Time_i] y tita[Time_i] con Time_i ≥ 200. NaN &lt; muoff da falso, así que el while (mui &lt; muoff) sale y el código de salida es 0. La pregunta física: ¿la descarga debe terminar por el potencial de corte (como el continuo) o por el tiempo nominal?</a:t>
+              <a:t>En el código (kmc_ckpt_refresco_ef.cpp:263-270): Crate = D·ℓ·3600/L², dt = capacidad/corriente = 3600/Crate segundos, pasobin = dt/200. Lo normal es que el corte llegue antes del tiempo nominal: la superficie se satura antes de que los iones lleguen al fondo y el SoC queda por debajo de 1. Las 7 corridas raras están todas arriba del mapa (log Ξ alto) con log ℓ = −2. Pregunta de fondo para los profes: ¿puede pasar en el modelo, o hay algo más que está mal?</a:t>
             </a:r>
             <a:endParaRPr lang="en-US" dirty="0"/>
           </a:p>
@@ -1133,7 +1134,7 @@
           <a:p>
             <a:r>
               <a:rPr lang="en-US" dirty="0"/>
-              <a:t>Los 13 g usan el mismo procedimiento que antes (grilla, bisección del acantilado y relleno), así que se puede comparar g por g contra los mapas viejos. El binario corregido tiene los arreglos 1 y 3; el 2 sigue pendiente.</a:t>
+              <a:t>En el código, líneas 337–348: MUs[Time_i] y tita[Time_i] con Time_i ≥ 200. NaN &lt; muoff da falso, así que el while (mui &lt; muoff) sale y el código de salida es 0. La pregunta física: ¿la descarga debe terminar por el potencial de corte (como el continuo) o por el tiempo nominal?</a:t>
             </a:r>
             <a:endParaRPr lang="en-US" dirty="0"/>
           </a:p>
@@ -1157,6 +1158,94 @@
             <a:fld id="{F7021451-1387-4CA6-816F-3879F97B5CBC}" type="slidenum">
               <a:rPr lang="en-US"/>
               <a:t>16</a:t>
+            </a:fld>
+            <a:endParaRPr lang="en-US"/>
+          </a:p>
+        </p:txBody>
+      </p:sp>
+    </p:spTree>
+    <p:extLst>
+      <p:ext uri="{BB962C8B-B14F-4D97-AF65-F5344CB8AC3E}">
+        <p14:creationId xmlns:p14="http://schemas.microsoft.com/office/powerpoint/2010/main" val="1024086991"/>
+      </p:ext>
+    </p:extLst>
+  </p:cSld>
+  <p:clrMapOvr>
+    <a:masterClrMapping/>
+  </p:clrMapOvr>
+</p:notes>
+</file>
+
+<file path=ppt/notesSlides/notesSlide17.xml><?xml version="1.0" encoding="utf-8"?>
+<p:notes xmlns:a="http://schemas.openxmlformats.org/drawingml/2006/main" xmlns:r="http://schemas.openxmlformats.org/officeDocument/2006/relationships" xmlns:p="http://schemas.openxmlformats.org/presentationml/2006/main">
+  <p:cSld>
+    <p:spTree>
+      <p:nvGrpSpPr>
+        <p:cNvPr id="1" name=""/>
+        <p:cNvGrpSpPr/>
+        <p:nvPr/>
+      </p:nvGrpSpPr>
+      <p:grpSpPr>
+        <a:xfrm>
+          <a:off x="0" y="0"/>
+          <a:ext cx="0" cy="0"/>
+          <a:chOff x="0" y="0"/>
+          <a:chExt cx="0" cy="0"/>
+        </a:xfrm>
+      </p:grpSpPr>
+      <p:sp>
+        <p:nvSpPr>
+          <p:cNvPr id="2" name="Slide Image Placeholder 1"/>
+          <p:cNvSpPr>
+            <a:spLocks noGrp="1" noRot="1" noChangeAspect="1"/>
+          </p:cNvSpPr>
+          <p:nvPr>
+            <p:ph type="sldImg"/>
+          </p:nvPr>
+        </p:nvSpPr>
+        <p:spPr/>
+      </p:sp>
+      <p:sp>
+        <p:nvSpPr>
+          <p:cNvPr id="3" name="Notes Placeholder 2"/>
+          <p:cNvSpPr>
+            <a:spLocks noGrp="1"/>
+          </p:cNvSpPr>
+          <p:nvPr>
+            <p:ph type="body" idx="1"/>
+          </p:nvPr>
+        </p:nvSpPr>
+        <p:spPr/>
+        <p:txBody>
+          <a:bodyPr/>
+          <a:lstStyle/>
+          <a:p>
+            <a:r>
+              <a:rPr lang="en-US" dirty="0"/>
+              <a:t>Los 13 g usan el mismo procedimiento que antes (grilla, bisección del acantilado y relleno), así que se puede comparar g por g contra los mapas viejos. El binario corregido tiene los arreglos 1 y 3; el 2 sigue pendiente.</a:t>
+            </a:r>
+            <a:endParaRPr lang="en-US" dirty="0"/>
+          </a:p>
+        </p:txBody>
+      </p:sp>
+      <p:sp>
+        <p:nvSpPr>
+          <p:cNvPr id="4" name="Slide Number Placeholder 3"/>
+          <p:cNvSpPr>
+            <a:spLocks noGrp="1"/>
+          </p:cNvSpPr>
+          <p:nvPr>
+            <p:ph type="sldNum" sz="quarter" idx="10"/>
+          </p:nvPr>
+        </p:nvSpPr>
+        <p:spPr/>
+        <p:txBody>
+          <a:bodyPr/>
+          <a:lstStyle/>
+          <a:p>
+            <a:fld id="{F7021451-1387-4CA6-816F-3879F97B5CBC}" type="slidenum">
+              <a:rPr lang="en-US"/>
+              <a:t>17</a:t>
             </a:fld>
             <a:endParaRPr lang="en-US"/>
           </a:p>
@@ -7250,6 +7339,933 @@
                 <a:ea typeface="Arial" pitchFamily="34" charset="-122"/>
                 <a:cs typeface="Arial" pitchFamily="34" charset="-120"/>
               </a:rPr>
+              <a:t>ERROR 2 · ANTES, EL TIEMPO NOMINAL</a:t>
+            </a:r>
+            <a:endParaRPr lang="en-US" sz="1300" dirty="0"/>
+          </a:p>
+        </p:txBody>
+      </p:sp>
+      <p:sp>
+        <p:nvSpPr>
+          <p:cNvPr id="3" name="Text 1"/>
+          <p:cNvSpPr/>
+          <p:nvPr>
+            <p:ph type="title"/>
+          </p:nvPr>
+        </p:nvSpPr>
+        <p:spPr>
+          <a:xfrm>
+            <a:off x="812800" y="1120080"/>
+            <a:ext cx="10883392" cy="444500"/>
+          </a:xfrm>
+          <a:prstGeom prst="rect">
+            <a:avLst/>
+          </a:prstGeom>
+          <a:noFill/>
+          <a:ln/>
+        </p:spPr>
+        <p:txBody>
+          <a:bodyPr wrap="square" lIns="0" tIns="0" rIns="0" bIns="0" rtlCol="0" anchor="t">
+            <a:normAutofit/>
+          </a:bodyPr>
+          <a:lstStyle/>
+          <a:p>
+            <a:pPr algn="l" indent="0" marL="0">
+              <a:lnSpc>
+                <a:spcPts val="3300"/>
+              </a:lnSpc>
+              <a:buNone/>
+            </a:pPr>
+            <a:r>
+              <a:rPr lang="en-US" sz="3000" b="1" i="0" dirty="0">
+                <a:solidFill>
+                  <a:srgbClr val="15233B"/>
+                </a:solidFill>
+                <a:latin typeface="Arial" pitchFamily="34" charset="0"/>
+                <a:ea typeface="Arial" pitchFamily="34" charset="-122"/>
+                <a:cs typeface="Arial" pitchFamily="34" charset="-120"/>
+              </a:rPr>
+              <a:t>El tiempo nominal: capacidad / corriente</a:t>
+            </a:r>
+            <a:endParaRPr lang="en-US" sz="3000" dirty="0"/>
+          </a:p>
+        </p:txBody>
+      </p:sp>
+      <p:sp>
+        <p:nvSpPr>
+          <p:cNvPr id="4" name="Shape 2"/>
+          <p:cNvSpPr/>
+          <p:nvPr/>
+        </p:nvSpPr>
+        <p:spPr>
+          <a:xfrm>
+            <a:off x="812800" y="1767780"/>
+            <a:ext cx="5168900" cy="1229221"/>
+          </a:xfrm>
+          <a:prstGeom prst="roundRect">
+            <a:avLst>
+              <a:gd name="adj" fmla="val 7232"/>
+            </a:avLst>
+          </a:prstGeom>
+          <a:solidFill>
+            <a:srgbClr val="15233B"/>
+          </a:solidFill>
+          <a:ln/>
+        </p:spPr>
+      </p:sp>
+      <p:sp>
+        <p:nvSpPr>
+          <p:cNvPr id="5" name="Text 3"/>
+          <p:cNvSpPr/>
+          <p:nvPr/>
+        </p:nvSpPr>
+        <p:spPr>
+          <a:xfrm>
+            <a:off x="1016000" y="1970980"/>
+            <a:ext cx="4905375" cy="309860"/>
+          </a:xfrm>
+          <a:prstGeom prst="rect">
+            <a:avLst/>
+          </a:prstGeom>
+          <a:noFill/>
+          <a:ln/>
+        </p:spPr>
+        <p:txBody>
+          <a:bodyPr wrap="square" lIns="0" tIns="0" rIns="0" bIns="0" rtlCol="0" anchor="t">
+            <a:normAutofit/>
+          </a:bodyPr>
+          <a:lstStyle/>
+          <a:p>
+            <a:pPr algn="l" indent="0" marL="0">
+              <a:lnSpc>
+                <a:spcPts val="2240"/>
+              </a:lnSpc>
+              <a:buNone/>
+            </a:pPr>
+            <a:r>
+              <a:rPr lang="en-US" sz="1600" dirty="0">
+                <a:solidFill>
+                  <a:srgbClr val="F6F5F0"/>
+                </a:solidFill>
+                <a:latin typeface="Courier New" pitchFamily="49" charset="0"/>
+                <a:ea typeface="Courier New" pitchFamily="49" charset="-122"/>
+                <a:cs typeface="Courier New" pitchFamily="49" charset="-120"/>
+              </a:rPr>
+              <a:t>t_nominal = capacidad / corriente</a:t>
+            </a:r>
+            <a:endParaRPr lang="en-US" sz="1600" dirty="0"/>
+          </a:p>
+        </p:txBody>
+      </p:sp>
+      <p:sp>
+        <p:nvSpPr>
+          <p:cNvPr id="6" name="Text 4"/>
+          <p:cNvSpPr/>
+          <p:nvPr/>
+        </p:nvSpPr>
+        <p:spPr>
+          <a:xfrm>
+            <a:off x="1016000" y="2331641"/>
+            <a:ext cx="4905375" cy="487561"/>
+          </a:xfrm>
+          <a:prstGeom prst="rect">
+            <a:avLst/>
+          </a:prstGeom>
+          <a:noFill/>
+          <a:ln/>
+        </p:spPr>
+        <p:txBody>
+          <a:bodyPr wrap="square" lIns="0" tIns="0" rIns="0" bIns="0" rtlCol="0" anchor="t">
+            <a:normAutofit/>
+          </a:bodyPr>
+          <a:lstStyle/>
+          <a:p>
+            <a:pPr algn="l" indent="0" marL="0">
+              <a:lnSpc>
+                <a:spcPts val="1820"/>
+              </a:lnSpc>
+              <a:buNone/>
+            </a:pPr>
+            <a:r>
+              <a:rPr lang="en-US" sz="1300" dirty="0">
+                <a:solidFill>
+                  <a:srgbClr val="BFC9D6"/>
+                </a:solidFill>
+                <a:latin typeface="Arial" pitchFamily="34" charset="0"/>
+                <a:ea typeface="Arial" pitchFamily="34" charset="-122"/>
+                <a:cs typeface="Arial" pitchFamily="34" charset="-120"/>
+              </a:rPr>
+              <a:t>Cuánto tardaría en llenarse el electrodo si todo lo que se empuja entrara. Botella de 1 litro, 1 litro por hora → 1 hora.</a:t>
+            </a:r>
+            <a:endParaRPr lang="en-US" sz="1300" dirty="0"/>
+          </a:p>
+        </p:txBody>
+      </p:sp>
+      <p:sp>
+        <p:nvSpPr>
+          <p:cNvPr id="7" name="Shape 5"/>
+          <p:cNvSpPr/>
+          <p:nvPr/>
+        </p:nvSpPr>
+        <p:spPr>
+          <a:xfrm>
+            <a:off x="6191250" y="1774130"/>
+            <a:ext cx="5181600" cy="1216521"/>
+          </a:xfrm>
+          <a:prstGeom prst="roundRect">
+            <a:avLst>
+              <a:gd name="adj" fmla="val 6786"/>
+            </a:avLst>
+          </a:prstGeom>
+          <a:solidFill>
+            <a:srgbClr val="FFFFFF"/>
+          </a:solidFill>
+          <a:ln w="12700">
+            <a:solidFill>
+              <a:srgbClr val="D5D9DF"/>
+            </a:solidFill>
+            <a:prstDash val="solid"/>
+          </a:ln>
+        </p:spPr>
+      </p:sp>
+      <p:sp>
+        <p:nvSpPr>
+          <p:cNvPr id="8" name="Text 6"/>
+          <p:cNvSpPr/>
+          <p:nvPr/>
+        </p:nvSpPr>
+        <p:spPr>
+          <a:xfrm>
+            <a:off x="6400800" y="1983680"/>
+            <a:ext cx="4905375" cy="256480"/>
+          </a:xfrm>
+          <a:prstGeom prst="rect">
+            <a:avLst/>
+          </a:prstGeom>
+          <a:noFill/>
+          <a:ln/>
+        </p:spPr>
+        <p:txBody>
+          <a:bodyPr wrap="square" lIns="0" tIns="0" rIns="0" bIns="0" rtlCol="0" anchor="t">
+            <a:normAutofit/>
+          </a:bodyPr>
+          <a:lstStyle/>
+          <a:p>
+            <a:pPr algn="l" indent="0" marL="0">
+              <a:lnSpc>
+                <a:spcPts val="1820"/>
+              </a:lnSpc>
+              <a:buNone/>
+            </a:pPr>
+            <a:r>
+              <a:rPr lang="en-US" sz="1300" b="1" dirty="0">
+                <a:solidFill>
+                  <a:srgbClr val="3E4A5C"/>
+                </a:solidFill>
+                <a:latin typeface="Arial" pitchFamily="34" charset="0"/>
+                <a:ea typeface="Arial" pitchFamily="34" charset="-122"/>
+                <a:cs typeface="Arial" pitchFamily="34" charset="-120"/>
+              </a:rPr>
+              <a:t>C-rate:</a:t>
+            </a:r>
+            <a:r>
+              <a:rPr lang="en-US" sz="1300" dirty="0">
+                <a:solidFill>
+                  <a:srgbClr val="3E4A5C"/>
+                </a:solidFill>
+                <a:latin typeface="Arial" pitchFamily="34" charset="0"/>
+                <a:ea typeface="Arial" pitchFamily="34" charset="-122"/>
+                <a:cs typeface="Arial" pitchFamily="34" charset="-120"/>
+              </a:rPr>
+              <a:t> 0.1C → 10 h · 1C → 1 h · 2C → 30 min</a:t>
+            </a:r>
+            <a:endParaRPr lang="en-US" sz="1300" dirty="0"/>
+          </a:p>
+        </p:txBody>
+      </p:sp>
+      <p:sp>
+        <p:nvSpPr>
+          <p:cNvPr id="9" name="Text 7"/>
+          <p:cNvSpPr/>
+          <p:nvPr/>
+        </p:nvSpPr>
+        <p:spPr>
+          <a:xfrm>
+            <a:off x="6400800" y="2290961"/>
+            <a:ext cx="4905375" cy="487561"/>
+          </a:xfrm>
+          <a:prstGeom prst="rect">
+            <a:avLst/>
+          </a:prstGeom>
+          <a:noFill/>
+          <a:ln/>
+        </p:spPr>
+        <p:txBody>
+          <a:bodyPr wrap="square" lIns="0" tIns="0" rIns="0" bIns="0" rtlCol="0" anchor="t">
+            <a:normAutofit/>
+          </a:bodyPr>
+          <a:lstStyle/>
+          <a:p>
+            <a:pPr algn="l" indent="0" marL="0">
+              <a:lnSpc>
+                <a:spcPts val="1820"/>
+              </a:lnSpc>
+              <a:buNone/>
+            </a:pPr>
+            <a:r>
+              <a:rPr lang="en-US" sz="1300" dirty="0">
+                <a:solidFill>
+                  <a:srgbClr val="3E4A5C"/>
+                </a:solidFill>
+                <a:latin typeface="Arial" pitchFamily="34" charset="0"/>
+                <a:ea typeface="Arial" pitchFamily="34" charset="-122"/>
+                <a:cs typeface="Arial" pitchFamily="34" charset="-120"/>
+              </a:rPr>
+              <a:t>En el KMC la C-rate sale de ℓ: </a:t>
+            </a:r>
+            <a:r>
+              <a:rPr lang="en-US" sz="1300" b="1" dirty="0">
+                <a:solidFill>
+                  <a:srgbClr val="3E4A5C"/>
+                </a:solidFill>
+                <a:latin typeface="Arial" pitchFamily="34" charset="0"/>
+                <a:ea typeface="Arial" pitchFamily="34" charset="-122"/>
+                <a:cs typeface="Arial" pitchFamily="34" charset="-120"/>
+              </a:rPr>
+              <a:t>ℓ alto = corriente alta = tiempo nominal corto</a:t>
+            </a:r>
+            <a:r>
+              <a:rPr lang="en-US" sz="1300" dirty="0">
+                <a:solidFill>
+                  <a:srgbClr val="3E4A5C"/>
+                </a:solidFill>
+                <a:latin typeface="Arial" pitchFamily="34" charset="0"/>
+                <a:ea typeface="Arial" pitchFamily="34" charset="-122"/>
+                <a:cs typeface="Arial" pitchFamily="34" charset="-120"/>
+              </a:rPr>
+              <a:t>. Por eso las corridas de ℓ bajo tardan días.</a:t>
+            </a:r>
+            <a:endParaRPr lang="en-US" sz="1300" dirty="0"/>
+          </a:p>
+        </p:txBody>
+      </p:sp>
+      <p:sp>
+        <p:nvSpPr>
+          <p:cNvPr id="10" name="Text 8"/>
+          <p:cNvSpPr/>
+          <p:nvPr/>
+        </p:nvSpPr>
+        <p:spPr>
+          <a:xfrm>
+            <a:off x="812800" y="3200202"/>
+            <a:ext cx="10883392" cy="256480"/>
+          </a:xfrm>
+          <a:prstGeom prst="rect">
+            <a:avLst/>
+          </a:prstGeom>
+          <a:noFill/>
+          <a:ln/>
+        </p:spPr>
+        <p:txBody>
+          <a:bodyPr wrap="square" lIns="0" tIns="0" rIns="0" bIns="0" rtlCol="0" anchor="t">
+            <a:normAutofit/>
+          </a:bodyPr>
+          <a:lstStyle/>
+          <a:p>
+            <a:pPr algn="l" indent="0" marL="0">
+              <a:lnSpc>
+                <a:spcPts val="1820"/>
+              </a:lnSpc>
+              <a:buNone/>
+            </a:pPr>
+            <a:r>
+              <a:rPr lang="en-US" sz="1300" dirty="0">
+                <a:solidFill>
+                  <a:srgbClr val="5B6B82"/>
+                </a:solidFill>
+                <a:latin typeface="Arial" pitchFamily="34" charset="0"/>
+                <a:ea typeface="Arial" pitchFamily="34" charset="-122"/>
+                <a:cs typeface="Arial" pitchFamily="34" charset="-120"/>
+              </a:rPr>
+              <a:t>El tiempo nominal se parte en 200 intervalos; al final de cada uno se escribe una fila de datos.</a:t>
+            </a:r>
+            <a:endParaRPr lang="en-US" sz="1300" dirty="0"/>
+          </a:p>
+        </p:txBody>
+      </p:sp>
+      <p:sp>
+        <p:nvSpPr>
+          <p:cNvPr id="11" name="Text 9"/>
+          <p:cNvSpPr/>
+          <p:nvPr/>
+        </p:nvSpPr>
+        <p:spPr>
+          <a:xfrm>
+            <a:off x="812800" y="3536652"/>
+            <a:ext cx="1003300" cy="256480"/>
+          </a:xfrm>
+          <a:prstGeom prst="rect">
+            <a:avLst/>
+          </a:prstGeom>
+          <a:noFill/>
+          <a:ln/>
+        </p:spPr>
+        <p:txBody>
+          <a:bodyPr wrap="square" lIns="0" tIns="0" rIns="0" bIns="0" rtlCol="0" anchor="t">
+            <a:normAutofit/>
+          </a:bodyPr>
+          <a:lstStyle/>
+          <a:p>
+            <a:pPr algn="l" indent="0" marL="0">
+              <a:lnSpc>
+                <a:spcPts val="1820"/>
+              </a:lnSpc>
+              <a:buNone/>
+            </a:pPr>
+            <a:r>
+              <a:rPr lang="en-US" sz="1300" b="1" dirty="0">
+                <a:solidFill>
+                  <a:srgbClr val="2563A6"/>
+                </a:solidFill>
+                <a:latin typeface="Arial" pitchFamily="34" charset="0"/>
+                <a:ea typeface="Arial" pitchFamily="34" charset="-122"/>
+                <a:cs typeface="Arial" pitchFamily="34" charset="-120"/>
+              </a:rPr>
+              <a:t>Lo normal</a:t>
+            </a:r>
+            <a:endParaRPr lang="en-US" sz="1300" dirty="0"/>
+          </a:p>
+        </p:txBody>
+      </p:sp>
+      <p:sp>
+        <p:nvSpPr>
+          <p:cNvPr id="12" name="Shape 10"/>
+          <p:cNvSpPr/>
+          <p:nvPr/>
+        </p:nvSpPr>
+        <p:spPr>
+          <a:xfrm>
+            <a:off x="1866900" y="3512542"/>
+            <a:ext cx="3888482" cy="279400"/>
+          </a:xfrm>
+          <a:custGeom>
+            <a:avLst/>
+            <a:gdLst/>
+            <a:ahLst/>
+            <a:cxnLst/>
+            <a:rect l="l" t="t" r="r" b="b"/>
+            <a:pathLst>
+              <a:path w="3888482" h="279400">
+                <a:moveTo>
+                  <a:pt x="50800" y="0"/>
+                </a:moveTo>
+                <a:lnTo>
+                  <a:pt x="3888482" y="0"/>
+                </a:lnTo>
+                <a:lnTo>
+                  <a:pt x="3888482" y="279400"/>
+                </a:lnTo>
+                <a:lnTo>
+                  <a:pt x="50800" y="279400"/>
+                </a:lnTo>
+                <a:arcTo hR="50800" wR="50800" stAng="5400000" swAng="5400000"/>
+                <a:lnTo>
+                  <a:pt x="0" y="50800"/>
+                </a:lnTo>
+                <a:arcTo hR="50800" wR="50800" stAng="10800000" swAng="5400000"/>
+                <a:close/>
+              </a:path>
+            </a:pathLst>
+          </a:custGeom>
+          <a:solidFill>
+            <a:srgbClr val="2563A6"/>
+          </a:solidFill>
+          <a:ln/>
+        </p:spPr>
+      </p:sp>
+      <p:sp>
+        <p:nvSpPr>
+          <p:cNvPr id="13" name="Text 11"/>
+          <p:cNvSpPr/>
+          <p:nvPr/>
+        </p:nvSpPr>
+        <p:spPr>
+          <a:xfrm>
+            <a:off x="5856982" y="3507482"/>
+            <a:ext cx="1202630" cy="289520"/>
+          </a:xfrm>
+          <a:prstGeom prst="roundRect">
+            <a:avLst>
+              <a:gd name="adj" fmla="val 17546"/>
+            </a:avLst>
+          </a:prstGeom>
+          <a:solidFill>
+            <a:srgbClr val="F0A35E"/>
+          </a:solidFill>
+          <a:ln/>
+        </p:spPr>
+        <p:txBody>
+          <a:bodyPr wrap="none" lIns="0" tIns="0" rIns="0" bIns="0" rtlCol="0" anchor="ctr">
+            <a:normAutofit/>
+          </a:bodyPr>
+          <a:lstStyle/>
+          <a:p>
+            <a:pPr algn="ctr" indent="0" marL="0">
+              <a:lnSpc>
+                <a:spcPts val="1680"/>
+              </a:lnSpc>
+              <a:buNone/>
+            </a:pPr>
+            <a:r>
+              <a:rPr lang="en-US" sz="1200" b="1" dirty="0">
+                <a:solidFill>
+                  <a:srgbClr val="15233B"/>
+                </a:solidFill>
+                <a:latin typeface="Arial" pitchFamily="34" charset="0"/>
+                <a:ea typeface="Arial" pitchFamily="34" charset="-122"/>
+                <a:cs typeface="Arial" pitchFamily="34" charset="-120"/>
+              </a:rPr>
+              <a:t>corte: SoC 0.6</a:t>
+            </a:r>
+            <a:endParaRPr lang="en-US" sz="1200" dirty="0"/>
+          </a:p>
+        </p:txBody>
+      </p:sp>
+      <p:sp>
+        <p:nvSpPr>
+          <p:cNvPr id="14" name="Shape 12"/>
+          <p:cNvSpPr/>
+          <p:nvPr/>
+        </p:nvSpPr>
+        <p:spPr>
+          <a:xfrm>
+            <a:off x="7161213" y="3512542"/>
+            <a:ext cx="2592388" cy="279400"/>
+          </a:xfrm>
+          <a:custGeom>
+            <a:avLst/>
+            <a:gdLst/>
+            <a:ahLst/>
+            <a:cxnLst/>
+            <a:rect l="l" t="t" r="r" b="b"/>
+            <a:pathLst>
+              <a:path w="2592388" h="279400">
+                <a:moveTo>
+                  <a:pt x="0" y="0"/>
+                </a:moveTo>
+                <a:lnTo>
+                  <a:pt x="2541588" y="0"/>
+                </a:lnTo>
+                <a:arcTo hR="50800" wR="50800" stAng="16200000" swAng="5400000"/>
+                <a:lnTo>
+                  <a:pt x="2592388" y="228600"/>
+                </a:lnTo>
+                <a:arcTo hR="50800" wR="50800" stAng="0" swAng="5400000"/>
+                <a:lnTo>
+                  <a:pt x="0" y="279400"/>
+                </a:lnTo>
+                <a:lnTo>
+                  <a:pt x="0" y="0"/>
+                </a:lnTo>
+                <a:close/>
+              </a:path>
+            </a:pathLst>
+          </a:custGeom>
+          <a:solidFill>
+            <a:srgbClr val="DCE1E8"/>
+          </a:solidFill>
+          <a:ln/>
+        </p:spPr>
+      </p:sp>
+      <p:sp>
+        <p:nvSpPr>
+          <p:cNvPr id="15" name="Text 13"/>
+          <p:cNvSpPr/>
+          <p:nvPr/>
+        </p:nvSpPr>
+        <p:spPr>
+          <a:xfrm>
+            <a:off x="9855200" y="3545582"/>
+            <a:ext cx="1574800" cy="238720"/>
+          </a:xfrm>
+          <a:prstGeom prst="rect">
+            <a:avLst/>
+          </a:prstGeom>
+          <a:noFill/>
+          <a:ln/>
+        </p:spPr>
+        <p:txBody>
+          <a:bodyPr wrap="square" lIns="0" tIns="0" rIns="0" bIns="0" rtlCol="0" anchor="t">
+            <a:normAutofit/>
+          </a:bodyPr>
+          <a:lstStyle/>
+          <a:p>
+            <a:pPr algn="l" indent="0" marL="0">
+              <a:lnSpc>
+                <a:spcPts val="1680"/>
+              </a:lnSpc>
+              <a:buNone/>
+            </a:pPr>
+            <a:r>
+              <a:rPr lang="en-US" sz="1200" dirty="0">
+                <a:solidFill>
+                  <a:srgbClr val="5B6B82"/>
+                </a:solidFill>
+                <a:latin typeface="Arial" pitchFamily="34" charset="0"/>
+                <a:ea typeface="Arial" pitchFamily="34" charset="-122"/>
+                <a:cs typeface="Arial" pitchFamily="34" charset="-120"/>
+              </a:rPr>
+              <a:t>tiempo nominal (200)</a:t>
+            </a:r>
+            <a:endParaRPr lang="en-US" sz="1200" dirty="0"/>
+          </a:p>
+        </p:txBody>
+      </p:sp>
+      <p:sp>
+        <p:nvSpPr>
+          <p:cNvPr id="16" name="Text 14"/>
+          <p:cNvSpPr/>
+          <p:nvPr/>
+        </p:nvSpPr>
+        <p:spPr>
+          <a:xfrm>
+            <a:off x="812800" y="3897313"/>
+            <a:ext cx="1003300" cy="256480"/>
+          </a:xfrm>
+          <a:prstGeom prst="rect">
+            <a:avLst/>
+          </a:prstGeom>
+          <a:noFill/>
+          <a:ln/>
+        </p:spPr>
+        <p:txBody>
+          <a:bodyPr wrap="square" lIns="0" tIns="0" rIns="0" bIns="0" rtlCol="0" anchor="t">
+            <a:normAutofit/>
+          </a:bodyPr>
+          <a:lstStyle/>
+          <a:p>
+            <a:pPr algn="l" indent="0" marL="0">
+              <a:lnSpc>
+                <a:spcPts val="1820"/>
+              </a:lnSpc>
+              <a:buNone/>
+            </a:pPr>
+            <a:r>
+              <a:rPr lang="en-US" sz="1300" b="1" dirty="0">
+                <a:solidFill>
+                  <a:srgbClr val="A8480E"/>
+                </a:solidFill>
+                <a:latin typeface="Arial" pitchFamily="34" charset="0"/>
+                <a:ea typeface="Arial" pitchFamily="34" charset="-122"/>
+                <a:cs typeface="Arial" pitchFamily="34" charset="-120"/>
+              </a:rPr>
+              <a:t>Lo raro</a:t>
+            </a:r>
+            <a:endParaRPr lang="en-US" sz="1300" dirty="0"/>
+          </a:p>
+        </p:txBody>
+      </p:sp>
+      <p:sp>
+        <p:nvSpPr>
+          <p:cNvPr id="17" name="Shape 15"/>
+          <p:cNvSpPr/>
+          <p:nvPr/>
+        </p:nvSpPr>
+        <p:spPr>
+          <a:xfrm>
+            <a:off x="1866900" y="3873202"/>
+            <a:ext cx="6642100" cy="279400"/>
+          </a:xfrm>
+          <a:prstGeom prst="roundRect">
+            <a:avLst>
+              <a:gd name="adj" fmla="val 18182"/>
+            </a:avLst>
+          </a:prstGeom>
+          <a:solidFill>
+            <a:srgbClr val="2563A6"/>
+          </a:solidFill>
+          <a:ln/>
+        </p:spPr>
+      </p:sp>
+      <p:sp>
+        <p:nvSpPr>
+          <p:cNvPr id="18" name="Shape 16"/>
+          <p:cNvSpPr/>
+          <p:nvPr/>
+        </p:nvSpPr>
+        <p:spPr>
+          <a:xfrm>
+            <a:off x="8620125" y="3882727"/>
+            <a:ext cx="1123950" cy="260350"/>
+          </a:xfrm>
+          <a:prstGeom prst="roundRect">
+            <a:avLst>
+              <a:gd name="adj" fmla="val 15854"/>
+            </a:avLst>
+          </a:prstGeom>
+          <a:noFill/>
+          <a:ln w="19050">
+            <a:solidFill>
+              <a:srgbClr val="D9661F"/>
+            </a:solidFill>
+            <a:prstDash val="dash"/>
+          </a:ln>
+        </p:spPr>
+      </p:sp>
+      <p:sp>
+        <p:nvSpPr>
+          <p:cNvPr id="19" name="Text 17"/>
+          <p:cNvSpPr/>
+          <p:nvPr/>
+        </p:nvSpPr>
+        <p:spPr>
+          <a:xfrm>
+            <a:off x="9855200" y="3906242"/>
+            <a:ext cx="1574800" cy="238720"/>
+          </a:xfrm>
+          <a:prstGeom prst="rect">
+            <a:avLst/>
+          </a:prstGeom>
+          <a:noFill/>
+          <a:ln/>
+        </p:spPr>
+        <p:txBody>
+          <a:bodyPr wrap="square" lIns="0" tIns="0" rIns="0" bIns="0" rtlCol="0" anchor="t">
+            <a:normAutofit/>
+          </a:bodyPr>
+          <a:lstStyle/>
+          <a:p>
+            <a:pPr algn="l" indent="0" marL="0">
+              <a:lnSpc>
+                <a:spcPts val="1680"/>
+              </a:lnSpc>
+              <a:buNone/>
+            </a:pPr>
+            <a:r>
+              <a:rPr lang="en-US" sz="1200" b="1" dirty="0">
+                <a:solidFill>
+                  <a:srgbClr val="A8480E"/>
+                </a:solidFill>
+                <a:latin typeface="Arial" pitchFamily="34" charset="0"/>
+                <a:ea typeface="Arial" pitchFamily="34" charset="-122"/>
+                <a:cs typeface="Arial" pitchFamily="34" charset="-120"/>
+              </a:rPr>
+              <a:t>201, 202… → NaN</a:t>
+            </a:r>
+            <a:endParaRPr lang="en-US" sz="1200" dirty="0"/>
+          </a:p>
+        </p:txBody>
+      </p:sp>
+      <p:sp>
+        <p:nvSpPr>
+          <p:cNvPr id="20" name="Text 18"/>
+          <p:cNvSpPr/>
+          <p:nvPr/>
+        </p:nvSpPr>
+        <p:spPr>
+          <a:xfrm>
+            <a:off x="812800" y="4228802"/>
+            <a:ext cx="10566400" cy="690761"/>
+          </a:xfrm>
+          <a:prstGeom prst="roundRect">
+            <a:avLst>
+              <a:gd name="adj" fmla="val 7354"/>
+            </a:avLst>
+          </a:prstGeom>
+          <a:solidFill>
+            <a:srgbClr val="FFF4EA"/>
+          </a:solidFill>
+          <a:ln/>
+        </p:spPr>
+        <p:txBody>
+          <a:bodyPr wrap="square" lIns="175621" tIns="99421" rIns="0" bIns="74021" rtlCol="0" anchor="t">
+            <a:normAutofit/>
+          </a:bodyPr>
+          <a:lstStyle/>
+          <a:p>
+            <a:pPr algn="l" indent="0" marL="0">
+              <a:lnSpc>
+                <a:spcPts val="1820"/>
+              </a:lnSpc>
+              <a:buNone/>
+            </a:pPr>
+            <a:r>
+              <a:rPr lang="en-US" sz="1300" dirty="0">
+                <a:solidFill>
+                  <a:srgbClr val="15233B"/>
+                </a:solidFill>
+                <a:latin typeface="Arial" pitchFamily="34" charset="0"/>
+                <a:ea typeface="Arial" pitchFamily="34" charset="-122"/>
+                <a:cs typeface="Arial" pitchFamily="34" charset="-120"/>
+              </a:rPr>
+              <a:t>Con el binario corregido, </a:t>
+            </a:r>
+            <a:r>
+              <a:rPr lang="en-US" sz="1300" b="1" dirty="0">
+                <a:solidFill>
+                  <a:srgbClr val="15233B"/>
+                </a:solidFill>
+                <a:latin typeface="Arial" pitchFamily="34" charset="0"/>
+                <a:ea typeface="Arial" pitchFamily="34" charset="-122"/>
+                <a:cs typeface="Arial" pitchFamily="34" charset="-120"/>
+              </a:rPr>
+              <a:t>7 de 153</a:t>
+            </a:r>
+            <a:r>
+              <a:rPr lang="en-US" sz="1300" dirty="0">
+                <a:solidFill>
+                  <a:srgbClr val="15233B"/>
+                </a:solidFill>
+                <a:latin typeface="Arial" pitchFamily="34" charset="0"/>
+                <a:ea typeface="Arial" pitchFamily="34" charset="-122"/>
+                <a:cs typeface="Arial" pitchFamily="34" charset="-120"/>
+              </a:rPr>
+              <a:t> corridas llegan al tiempo nominal con SoC 0.87–0.97 y E ≈ +0.03 V (corte: −0.149 V). Si todo lo empujado hubiera entrado, el SoC sería 1 y ya habría cortado: </a:t>
+            </a:r>
+            <a:r>
+              <a:rPr lang="en-US" sz="1300" b="1" dirty="0">
+                <a:solidFill>
+                  <a:srgbClr val="15233B"/>
+                </a:solidFill>
+                <a:latin typeface="Arial" pitchFamily="34" charset="0"/>
+                <a:ea typeface="Arial" pitchFamily="34" charset="-122"/>
+                <a:cs typeface="Arial" pitchFamily="34" charset="-120"/>
+              </a:rPr>
+              <a:t>entró menos de lo que dice la corriente</a:t>
+            </a:r>
+            <a:r>
+              <a:rPr lang="en-US" sz="1300" dirty="0">
+                <a:solidFill>
+                  <a:srgbClr val="15233B"/>
+                </a:solidFill>
+                <a:latin typeface="Arial" pitchFamily="34" charset="0"/>
+                <a:ea typeface="Arial" pitchFamily="34" charset="-122"/>
+                <a:cs typeface="Arial" pitchFamily="34" charset="-120"/>
+              </a:rPr>
+              <a:t>.</a:t>
+            </a:r>
+            <a:endParaRPr lang="en-US" sz="1300" dirty="0"/>
+          </a:p>
+        </p:txBody>
+      </p:sp>
+      <p:sp>
+        <p:nvSpPr>
+          <p:cNvPr id="21" name="Shape 19"/>
+          <p:cNvSpPr/>
+          <p:nvPr/>
+        </p:nvSpPr>
+        <p:spPr>
+          <a:xfrm>
+            <a:off x="812800" y="4228802"/>
+            <a:ext cx="10566400" cy="690761"/>
+          </a:xfrm>
+          <a:custGeom>
+            <a:avLst/>
+            <a:gdLst/>
+            <a:ahLst/>
+            <a:cxnLst/>
+            <a:rect l="l" t="t" r="r" b="b"/>
+            <a:pathLst>
+              <a:path w="10566400" h="690761">
+                <a:moveTo>
+                  <a:pt x="50800" y="690761"/>
+                </a:moveTo>
+                <a:lnTo>
+                  <a:pt x="50800" y="690761"/>
+                </a:lnTo>
+                <a:arcTo hR="50800" wR="50800" stAng="5400000" swAng="5400000"/>
+                <a:lnTo>
+                  <a:pt x="0" y="50800"/>
+                </a:lnTo>
+                <a:arcTo hR="50800" wR="50800" stAng="10800000" swAng="5400000"/>
+                <a:lnTo>
+                  <a:pt x="50800" y="0"/>
+                </a:lnTo>
+                <a:arcTo hR="50800" wR="12700" stAng="16200000" swAng="-5400000"/>
+                <a:lnTo>
+                  <a:pt x="38100" y="639961"/>
+                </a:lnTo>
+                <a:arcTo hR="50800" wR="12700" stAng="10800000" swAng="-5400000"/>
+                <a:close/>
+              </a:path>
+            </a:pathLst>
+          </a:custGeom>
+          <a:solidFill>
+            <a:srgbClr val="D9661F"/>
+          </a:solidFill>
+          <a:ln/>
+        </p:spPr>
+      </p:sp>
+    </p:spTree>
+  </p:cSld>
+  <p:clrMapOvr>
+    <a:masterClrMapping/>
+  </p:clrMapOvr>
+</p:sld>
+</file>
+
+<file path=ppt/slides/slide16.xml><?xml version="1.0" encoding="utf-8"?>
+<p:sld xmlns:a="http://schemas.openxmlformats.org/drawingml/2006/main" xmlns:r="http://schemas.openxmlformats.org/officeDocument/2006/relationships" xmlns:p="http://schemas.openxmlformats.org/presentationml/2006/main">
+  <p:cSld name="Slide 16">
+    <p:bg>
+      <p:bgPr>
+        <a:solidFill>
+          <a:srgbClr val="F6F5F0"/>
+        </a:solidFill>
+      </p:bgPr>
+    </p:bg>
+    <p:spTree>
+      <p:nvGrpSpPr>
+        <p:cNvPr id="1" name=""/>
+        <p:cNvGrpSpPr/>
+        <p:nvPr/>
+      </p:nvGrpSpPr>
+      <p:grpSpPr>
+        <a:xfrm>
+          <a:off x="0" y="0"/>
+          <a:ext cx="0" cy="0"/>
+          <a:chOff x="0" y="0"/>
+          <a:chExt cx="0" cy="0"/>
+        </a:xfrm>
+      </p:grpSpPr>
+      <p:sp>
+        <p:nvSpPr>
+          <p:cNvPr id="2" name="Text 0"/>
+          <p:cNvSpPr/>
+          <p:nvPr/>
+        </p:nvSpPr>
+        <p:spPr>
+          <a:xfrm>
+            <a:off x="812800" y="812800"/>
+            <a:ext cx="10883392" cy="256480"/>
+          </a:xfrm>
+          <a:prstGeom prst="rect">
+            <a:avLst/>
+          </a:prstGeom>
+          <a:noFill/>
+          <a:ln/>
+        </p:spPr>
+        <p:txBody>
+          <a:bodyPr wrap="square" lIns="0" tIns="0" rIns="0" bIns="0" rtlCol="0" anchor="t">
+            <a:normAutofit/>
+          </a:bodyPr>
+          <a:lstStyle/>
+          <a:p>
+            <a:pPr algn="l" indent="0" marL="0">
+              <a:lnSpc>
+                <a:spcPts val="1820"/>
+              </a:lnSpc>
+              <a:buNone/>
+            </a:pPr>
+            <a:r>
+              <a:rPr lang="en-US" sz="1300" b="1" spc="100" kern="0" dirty="0">
+                <a:solidFill>
+                  <a:srgbClr val="D9661F"/>
+                </a:solidFill>
+                <a:latin typeface="Arial" pitchFamily="34" charset="0"/>
+                <a:ea typeface="Arial" pitchFamily="34" charset="-122"/>
+                <a:cs typeface="Arial" pitchFamily="34" charset="-120"/>
+              </a:rPr>
               <a:t>ERROR 2 · NUMÉRICO</a:t>
             </a:r>
             <a:endParaRPr lang="en-US" sz="1300" dirty="0"/>
@@ -8386,9 +9402,9 @@
 </p:sld>
 </file>
 
-<file path=ppt/slides/slide16.xml><?xml version="1.0" encoding="utf-8"?>
+<file path=ppt/slides/slide17.xml><?xml version="1.0" encoding="utf-8"?>
 <p:sld xmlns:a="http://schemas.openxmlformats.org/drawingml/2006/main" xmlns:r="http://schemas.openxmlformats.org/officeDocument/2006/relationships" xmlns:p="http://schemas.openxmlformats.org/presentationml/2006/main">
-  <p:cSld name="Slide 16">
+  <p:cSld name="Slide 17">
     <p:bg>
       <p:bgPr>
         <a:solidFill>
@@ -19622,10 +20638,10 @@
         <a:srgbClr val="A8480E"/>
       </a:accent3>
       <a:accent4>
-        <a:srgbClr val="F0A35E"/>
+        <a:srgbClr val="5B6B82"/>
       </a:accent4>
       <a:accent5>
-        <a:srgbClr val="5B6B82"/>
+        <a:srgbClr val="F0A35E"/>
       </a:accent5>
       <a:accent6>
         <a:srgbClr val="2B4A72"/>

</xml_diff>